<commit_message>
cleanup, deleted all intermediary plots
</commit_message>
<xml_diff>
--- a/Astro_Presentation.pptx
+++ b/Astro_Presentation.pptx
@@ -5,13 +5,17 @@
     <p:sldMasterId id="2147483648" r:id="rId1"/>
   </p:sldMasterIdLst>
   <p:notesMasterIdLst>
-    <p:notesMasterId r:id="rId6"/>
+    <p:notesMasterId r:id="rId10"/>
   </p:notesMasterIdLst>
   <p:sldIdLst>
     <p:sldId id="256" r:id="rId2"/>
     <p:sldId id="257" r:id="rId3"/>
-    <p:sldId id="258" r:id="rId4"/>
-    <p:sldId id="259" r:id="rId5"/>
+    <p:sldId id="260" r:id="rId4"/>
+    <p:sldId id="258" r:id="rId5"/>
+    <p:sldId id="259" r:id="rId6"/>
+    <p:sldId id="261" r:id="rId7"/>
+    <p:sldId id="262" r:id="rId8"/>
+    <p:sldId id="263" r:id="rId9"/>
   </p:sldIdLst>
   <p:sldSz cx="12192000" cy="6858000"/>
   <p:notesSz cx="6858000" cy="9144000"/>
@@ -118,12 +122,20 @@
 </p:presentation>
 </file>
 
+<file path=ppt/revisionInfo.xml><?xml version="1.0" encoding="utf-8"?>
+<p1510:revInfo xmlns:a="http://schemas.openxmlformats.org/drawingml/2006/main" xmlns:r="http://schemas.openxmlformats.org/officeDocument/2006/relationships" xmlns:p1510="http://schemas.microsoft.com/office/powerpoint/2015/10/main">
+  <p1510:revLst>
+    <p1510:client id="{AD700C3E-21DA-4553-A518-0964B2E2D32A}" v="2" dt="2026-01-26T12:22:09.625"/>
+  </p1510:revLst>
+</p1510:revInfo>
+</file>
+
 <file path=ppt/changesInfos/changesInfo1.xml><?xml version="1.0" encoding="utf-8"?>
 <pc:chgInfo xmlns:a="http://schemas.openxmlformats.org/drawingml/2006/main" xmlns:r="http://schemas.openxmlformats.org/officeDocument/2006/relationships" xmlns:ac="http://schemas.microsoft.com/office/drawing/2013/main/command" xmlns:pc="http://schemas.microsoft.com/office/powerpoint/2013/main/command">
   <pc:docChgLst>
     <pc:chgData name="Diego Söldi" userId="ffa27cb0-8acc-4ea6-85a9-699722391c58" providerId="ADAL" clId="{0E03A2A5-F04A-47FD-9A60-A114FA7BEEB8}"/>
     <pc:docChg chg="undo custSel addSld delSld modSld modMainMaster">
-      <pc:chgData name="Diego Söldi" userId="ffa27cb0-8acc-4ea6-85a9-699722391c58" providerId="ADAL" clId="{0E03A2A5-F04A-47FD-9A60-A114FA7BEEB8}" dt="2026-01-25T15:36:33.819" v="5969" actId="20577"/>
+      <pc:chgData name="Diego Söldi" userId="ffa27cb0-8acc-4ea6-85a9-699722391c58" providerId="ADAL" clId="{0E03A2A5-F04A-47FD-9A60-A114FA7BEEB8}" dt="2026-01-26T12:23:11.597" v="6863" actId="20577"/>
       <pc:docMkLst>
         <pc:docMk/>
       </pc:docMkLst>
@@ -158,13 +170,13 @@
         </pc:spChg>
       </pc:sldChg>
       <pc:sldChg chg="modSp new mod">
-        <pc:chgData name="Diego Söldi" userId="ffa27cb0-8acc-4ea6-85a9-699722391c58" providerId="ADAL" clId="{0E03A2A5-F04A-47FD-9A60-A114FA7BEEB8}" dt="2026-01-25T15:27:48.728" v="5621" actId="20577"/>
+        <pc:chgData name="Diego Söldi" userId="ffa27cb0-8acc-4ea6-85a9-699722391c58" providerId="ADAL" clId="{0E03A2A5-F04A-47FD-9A60-A114FA7BEEB8}" dt="2026-01-26T12:11:35.441" v="6131" actId="20577"/>
         <pc:sldMkLst>
           <pc:docMk/>
           <pc:sldMk cId="2451972814" sldId="257"/>
         </pc:sldMkLst>
         <pc:spChg chg="mod">
-          <ac:chgData name="Diego Söldi" userId="ffa27cb0-8acc-4ea6-85a9-699722391c58" providerId="ADAL" clId="{0E03A2A5-F04A-47FD-9A60-A114FA7BEEB8}" dt="2026-01-25T15:26:26.529" v="5443" actId="20577"/>
+          <ac:chgData name="Diego Söldi" userId="ffa27cb0-8acc-4ea6-85a9-699722391c58" providerId="ADAL" clId="{0E03A2A5-F04A-47FD-9A60-A114FA7BEEB8}" dt="2026-01-26T12:11:35.441" v="6131" actId="20577"/>
           <ac:spMkLst>
             <pc:docMk/>
             <pc:sldMk cId="2451972814" sldId="257"/>
@@ -195,13 +207,13 @@
         </pc:sldMkLst>
       </pc:sldChg>
       <pc:sldChg chg="modSp new mod">
-        <pc:chgData name="Diego Söldi" userId="ffa27cb0-8acc-4ea6-85a9-699722391c58" providerId="ADAL" clId="{0E03A2A5-F04A-47FD-9A60-A114FA7BEEB8}" dt="2026-01-25T15:35:19.532" v="5733" actId="20577"/>
+        <pc:chgData name="Diego Söldi" userId="ffa27cb0-8acc-4ea6-85a9-699722391c58" providerId="ADAL" clId="{0E03A2A5-F04A-47FD-9A60-A114FA7BEEB8}" dt="2026-01-26T12:10:56.124" v="6042" actId="20577"/>
         <pc:sldMkLst>
           <pc:docMk/>
           <pc:sldMk cId="3228109496" sldId="258"/>
         </pc:sldMkLst>
         <pc:spChg chg="mod">
-          <ac:chgData name="Diego Söldi" userId="ffa27cb0-8acc-4ea6-85a9-699722391c58" providerId="ADAL" clId="{0E03A2A5-F04A-47FD-9A60-A114FA7BEEB8}" dt="2026-01-25T15:26:33.712" v="5454" actId="20577"/>
+          <ac:chgData name="Diego Söldi" userId="ffa27cb0-8acc-4ea6-85a9-699722391c58" providerId="ADAL" clId="{0E03A2A5-F04A-47FD-9A60-A114FA7BEEB8}" dt="2026-01-26T12:10:56.124" v="6042" actId="20577"/>
           <ac:spMkLst>
             <pc:docMk/>
             <pc:sldMk cId="3228109496" sldId="258"/>
@@ -209,7 +221,7 @@
           </ac:spMkLst>
         </pc:spChg>
         <pc:spChg chg="mod">
-          <ac:chgData name="Diego Söldi" userId="ffa27cb0-8acc-4ea6-85a9-699722391c58" providerId="ADAL" clId="{0E03A2A5-F04A-47FD-9A60-A114FA7BEEB8}" dt="2026-01-25T15:35:19.532" v="5733" actId="20577"/>
+          <ac:chgData name="Diego Söldi" userId="ffa27cb0-8acc-4ea6-85a9-699722391c58" providerId="ADAL" clId="{0E03A2A5-F04A-47FD-9A60-A114FA7BEEB8}" dt="2026-01-26T12:10:30.553" v="5998" actId="20577"/>
           <ac:spMkLst>
             <pc:docMk/>
             <pc:sldMk cId="3228109496" sldId="258"/>
@@ -247,6 +259,44 @@
           <pc:sldMk cId="2144067929" sldId="260"/>
         </pc:sldMkLst>
       </pc:sldChg>
+      <pc:sldChg chg="modSp new mod">
+        <pc:chgData name="Diego Söldi" userId="ffa27cb0-8acc-4ea6-85a9-699722391c58" providerId="ADAL" clId="{0E03A2A5-F04A-47FD-9A60-A114FA7BEEB8}" dt="2026-01-26T12:12:00.866" v="6157" actId="20577"/>
+        <pc:sldMkLst>
+          <pc:docMk/>
+          <pc:sldMk cId="3537959711" sldId="260"/>
+        </pc:sldMkLst>
+        <pc:spChg chg="mod">
+          <ac:chgData name="Diego Söldi" userId="ffa27cb0-8acc-4ea6-85a9-699722391c58" providerId="ADAL" clId="{0E03A2A5-F04A-47FD-9A60-A114FA7BEEB8}" dt="2026-01-26T12:12:00.866" v="6157" actId="20577"/>
+          <ac:spMkLst>
+            <pc:docMk/>
+            <pc:sldMk cId="3537959711" sldId="260"/>
+            <ac:spMk id="2" creationId="{A959B456-38AD-AFDF-3854-2356686DBFDB}"/>
+          </ac:spMkLst>
+        </pc:spChg>
+      </pc:sldChg>
+      <pc:sldChg chg="modSp new mod modShow">
+        <pc:chgData name="Diego Söldi" userId="ffa27cb0-8acc-4ea6-85a9-699722391c58" providerId="ADAL" clId="{0E03A2A5-F04A-47FD-9A60-A114FA7BEEB8}" dt="2026-01-26T12:21:11.142" v="6504" actId="20577"/>
+        <pc:sldMkLst>
+          <pc:docMk/>
+          <pc:sldMk cId="2075024410" sldId="261"/>
+        </pc:sldMkLst>
+        <pc:spChg chg="mod">
+          <ac:chgData name="Diego Söldi" userId="ffa27cb0-8acc-4ea6-85a9-699722391c58" providerId="ADAL" clId="{0E03A2A5-F04A-47FD-9A60-A114FA7BEEB8}" dt="2026-01-26T12:19:26.241" v="6279" actId="27636"/>
+          <ac:spMkLst>
+            <pc:docMk/>
+            <pc:sldMk cId="2075024410" sldId="261"/>
+            <ac:spMk id="2" creationId="{AAEC1150-26B3-CCE0-11A1-3B5A92A302C4}"/>
+          </ac:spMkLst>
+        </pc:spChg>
+        <pc:spChg chg="mod">
+          <ac:chgData name="Diego Söldi" userId="ffa27cb0-8acc-4ea6-85a9-699722391c58" providerId="ADAL" clId="{0E03A2A5-F04A-47FD-9A60-A114FA7BEEB8}" dt="2026-01-26T12:21:11.142" v="6504" actId="20577"/>
+          <ac:spMkLst>
+            <pc:docMk/>
+            <pc:sldMk cId="2075024410" sldId="261"/>
+            <ac:spMk id="3" creationId="{1A2A4AF0-4310-3FB5-1104-99A8D907DF5C}"/>
+          </ac:spMkLst>
+        </pc:spChg>
+      </pc:sldChg>
       <pc:sldChg chg="addSp delSp modSp add del mod modNotesTx">
         <pc:chgData name="Diego Söldi" userId="ffa27cb0-8acc-4ea6-85a9-699722391c58" providerId="ADAL" clId="{0E03A2A5-F04A-47FD-9A60-A114FA7BEEB8}" dt="2026-01-25T15:25:06.465" v="5361" actId="47"/>
         <pc:sldMkLst>
@@ -261,12 +311,58 @@
           <pc:sldMk cId="2582884232" sldId="262"/>
         </pc:sldMkLst>
       </pc:sldChg>
+      <pc:sldChg chg="modSp add mod">
+        <pc:chgData name="Diego Söldi" userId="ffa27cb0-8acc-4ea6-85a9-699722391c58" providerId="ADAL" clId="{0E03A2A5-F04A-47FD-9A60-A114FA7BEEB8}" dt="2026-01-26T12:22:04.848" v="6630" actId="20577"/>
+        <pc:sldMkLst>
+          <pc:docMk/>
+          <pc:sldMk cId="4010987809" sldId="262"/>
+        </pc:sldMkLst>
+        <pc:spChg chg="mod">
+          <ac:chgData name="Diego Söldi" userId="ffa27cb0-8acc-4ea6-85a9-699722391c58" providerId="ADAL" clId="{0E03A2A5-F04A-47FD-9A60-A114FA7BEEB8}" dt="2026-01-26T12:21:31.663" v="6549" actId="20577"/>
+          <ac:spMkLst>
+            <pc:docMk/>
+            <pc:sldMk cId="4010987809" sldId="262"/>
+            <ac:spMk id="2" creationId="{7AAB86AA-B3BE-3132-E482-860F90ED34DB}"/>
+          </ac:spMkLst>
+        </pc:spChg>
+        <pc:spChg chg="mod">
+          <ac:chgData name="Diego Söldi" userId="ffa27cb0-8acc-4ea6-85a9-699722391c58" providerId="ADAL" clId="{0E03A2A5-F04A-47FD-9A60-A114FA7BEEB8}" dt="2026-01-26T12:22:04.848" v="6630" actId="20577"/>
+          <ac:spMkLst>
+            <pc:docMk/>
+            <pc:sldMk cId="4010987809" sldId="262"/>
+            <ac:spMk id="3" creationId="{D3594631-2842-0B40-A0B1-9187BF7AC3BB}"/>
+          </ac:spMkLst>
+        </pc:spChg>
+      </pc:sldChg>
       <pc:sldChg chg="addSp modSp new del mod">
         <pc:chgData name="Diego Söldi" userId="ffa27cb0-8acc-4ea6-85a9-699722391c58" providerId="ADAL" clId="{0E03A2A5-F04A-47FD-9A60-A114FA7BEEB8}" dt="2026-01-25T15:25:06.465" v="5361" actId="47"/>
         <pc:sldMkLst>
           <pc:docMk/>
           <pc:sldMk cId="3976398254" sldId="263"/>
         </pc:sldMkLst>
+      </pc:sldChg>
+      <pc:sldChg chg="modSp add mod">
+        <pc:chgData name="Diego Söldi" userId="ffa27cb0-8acc-4ea6-85a9-699722391c58" providerId="ADAL" clId="{0E03A2A5-F04A-47FD-9A60-A114FA7BEEB8}" dt="2026-01-26T12:23:11.597" v="6863" actId="20577"/>
+        <pc:sldMkLst>
+          <pc:docMk/>
+          <pc:sldMk cId="4166035770" sldId="263"/>
+        </pc:sldMkLst>
+        <pc:spChg chg="mod">
+          <ac:chgData name="Diego Söldi" userId="ffa27cb0-8acc-4ea6-85a9-699722391c58" providerId="ADAL" clId="{0E03A2A5-F04A-47FD-9A60-A114FA7BEEB8}" dt="2026-01-26T12:22:17.149" v="6650" actId="20577"/>
+          <ac:spMkLst>
+            <pc:docMk/>
+            <pc:sldMk cId="4166035770" sldId="263"/>
+            <ac:spMk id="2" creationId="{F993A75E-75C7-3FB9-8C74-AAD87356867C}"/>
+          </ac:spMkLst>
+        </pc:spChg>
+        <pc:spChg chg="mod">
+          <ac:chgData name="Diego Söldi" userId="ffa27cb0-8acc-4ea6-85a9-699722391c58" providerId="ADAL" clId="{0E03A2A5-F04A-47FD-9A60-A114FA7BEEB8}" dt="2026-01-26T12:23:11.597" v="6863" actId="20577"/>
+          <ac:spMkLst>
+            <pc:docMk/>
+            <pc:sldMk cId="4166035770" sldId="263"/>
+            <ac:spMk id="3" creationId="{C418CF10-EC3D-94A3-9152-1EC15A4DCE8E}"/>
+          </ac:spMkLst>
+        </pc:spChg>
       </pc:sldChg>
     </pc:docChg>
   </pc:docChgLst>
@@ -355,7 +451,7 @@
           <a:p>
             <a:fld id="{45796FAE-8AEC-44A0-86C0-32CAD4FB1DE3}" type="datetimeFigureOut">
               <a:rPr lang="de-CH" smtClean="0"/>
-              <a:t>25.01.2026</a:t>
+              <a:t>26.01.2026</a:t>
             </a:fld>
             <a:endParaRPr lang="de-CH"/>
           </a:p>
@@ -772,7 +868,7 @@
           <a:p>
             <a:fld id="{2F38449A-47A8-4D03-A39F-C67C66585C65}" type="datetime1">
               <a:rPr lang="de-CH" smtClean="0"/>
-              <a:t>25.01.2026</a:t>
+              <a:t>26.01.2026</a:t>
             </a:fld>
             <a:endParaRPr lang="de-CH"/>
           </a:p>
@@ -975,7 +1071,7 @@
           <a:p>
             <a:fld id="{04805FD9-7671-4C54-AAA8-B38BD4BF611B}" type="datetime1">
               <a:rPr lang="de-CH" smtClean="0"/>
-              <a:t>25.01.2026</a:t>
+              <a:t>26.01.2026</a:t>
             </a:fld>
             <a:endParaRPr lang="de-CH"/>
           </a:p>
@@ -1188,7 +1284,7 @@
           <a:p>
             <a:fld id="{4DF4B6CA-42D3-424F-979F-BBCFA85BCA1F}" type="datetime1">
               <a:rPr lang="de-CH" smtClean="0"/>
-              <a:t>25.01.2026</a:t>
+              <a:t>26.01.2026</a:t>
             </a:fld>
             <a:endParaRPr lang="de-CH"/>
           </a:p>
@@ -1391,7 +1487,7 @@
           <a:p>
             <a:fld id="{A6EC175A-E8C4-4C20-9819-5DBDC27D5282}" type="datetime1">
               <a:rPr lang="de-CH" smtClean="0"/>
-              <a:t>25.01.2026</a:t>
+              <a:t>26.01.2026</a:t>
             </a:fld>
             <a:endParaRPr lang="de-CH"/>
           </a:p>
@@ -1670,7 +1766,7 @@
           <a:p>
             <a:fld id="{4063CC9F-E7C0-459E-987A-53E2E34E765F}" type="datetime1">
               <a:rPr lang="de-CH" smtClean="0"/>
-              <a:t>25.01.2026</a:t>
+              <a:t>26.01.2026</a:t>
             </a:fld>
             <a:endParaRPr lang="de-CH"/>
           </a:p>
@@ -1941,7 +2037,7 @@
           <a:p>
             <a:fld id="{A08DB447-DFF0-4647-ADDD-AD1CE145FC39}" type="datetime1">
               <a:rPr lang="de-CH" smtClean="0"/>
-              <a:t>25.01.2026</a:t>
+              <a:t>26.01.2026</a:t>
             </a:fld>
             <a:endParaRPr lang="de-CH"/>
           </a:p>
@@ -2359,7 +2455,7 @@
           <a:p>
             <a:fld id="{D01F6430-753F-42D6-9489-209682ACB659}" type="datetime1">
               <a:rPr lang="de-CH" smtClean="0"/>
-              <a:t>25.01.2026</a:t>
+              <a:t>26.01.2026</a:t>
             </a:fld>
             <a:endParaRPr lang="de-CH"/>
           </a:p>
@@ -2504,7 +2600,7 @@
           <a:p>
             <a:fld id="{4511CAC0-2315-4752-8681-F21464DBA247}" type="datetime1">
               <a:rPr lang="de-CH" smtClean="0"/>
-              <a:t>25.01.2026</a:t>
+              <a:t>26.01.2026</a:t>
             </a:fld>
             <a:endParaRPr lang="de-CH"/>
           </a:p>
@@ -2620,7 +2716,7 @@
           <a:p>
             <a:fld id="{9D718A6C-9D4F-4745-8B14-40B5ABBA5479}" type="datetime1">
               <a:rPr lang="de-CH" smtClean="0"/>
-              <a:t>25.01.2026</a:t>
+              <a:t>26.01.2026</a:t>
             </a:fld>
             <a:endParaRPr lang="de-CH"/>
           </a:p>
@@ -2936,7 +3032,7 @@
           <a:p>
             <a:fld id="{2B83CF53-C60C-4364-87CB-28CB1A2F7977}" type="datetime1">
               <a:rPr lang="de-CH" smtClean="0"/>
-              <a:t>25.01.2026</a:t>
+              <a:t>26.01.2026</a:t>
             </a:fld>
             <a:endParaRPr lang="de-CH"/>
           </a:p>
@@ -3228,7 +3324,7 @@
           <a:p>
             <a:fld id="{DEB1BB2F-5C48-4756-B9F1-377D4A643E3C}" type="datetime1">
               <a:rPr lang="de-CH" smtClean="0"/>
-              <a:t>25.01.2026</a:t>
+              <a:t>26.01.2026</a:t>
             </a:fld>
             <a:endParaRPr lang="de-CH"/>
           </a:p>
@@ -3474,7 +3570,7 @@
           <a:p>
             <a:fld id="{485D1722-D9F3-4CB0-882D-B61D80B03A69}" type="datetime1">
               <a:rPr lang="de-CH" smtClean="0"/>
-              <a:t>25.01.2026</a:t>
+              <a:t>26.01.2026</a:t>
             </a:fld>
             <a:endParaRPr lang="de-CH"/>
           </a:p>
@@ -4087,12 +4183,18 @@
         </p:nvSpPr>
         <p:spPr/>
         <p:txBody>
-          <a:bodyPr/>
-          <a:lstStyle/>
-          <a:p>
-            <a:r>
-              <a:rPr lang="de-DE" dirty="0"/>
-              <a:t>Task 1</a:t>
+          <a:bodyPr>
+            <a:normAutofit fontScale="90000"/>
+          </a:bodyPr>
+          <a:lstStyle/>
+          <a:p>
+            <a:r>
+              <a:rPr lang="de-DE" dirty="0"/>
+              <a:t>Task 1 – Distribution &amp; Relaxation </a:t>
+            </a:r>
+            <a:r>
+              <a:rPr lang="de-DE" dirty="0" err="1"/>
+              <a:t>Timescale</a:t>
             </a:r>
             <a:endParaRPr lang="de-CH" dirty="0"/>
           </a:p>
@@ -4308,7 +4410,7 @@
           <p:cNvPr id="2" name="Titel 1">
             <a:extLst>
               <a:ext uri="{FF2B5EF4-FFF2-40B4-BE49-F238E27FC236}">
-                <a16:creationId xmlns:a16="http://schemas.microsoft.com/office/drawing/2014/main" id="{C703E5DC-2AF6-6DE0-E527-428B98CE8FE5}"/>
+                <a16:creationId xmlns:a16="http://schemas.microsoft.com/office/drawing/2014/main" id="{A959B456-38AD-AFDF-3854-2356686DBFDB}"/>
               </a:ext>
             </a:extLst>
           </p:cNvPr>
@@ -4325,8 +4427,12 @@
           <a:lstStyle/>
           <a:p>
             <a:r>
-              <a:rPr lang="de-DE" dirty="0"/>
-              <a:t>Task 2</a:t>
+              <a:rPr lang="de-DE" dirty="0" err="1"/>
+              <a:t>Hernquist</a:t>
+            </a:r>
+            <a:r>
+              <a:rPr lang="de-DE" dirty="0"/>
+              <a:t> Profile</a:t>
             </a:r>
             <a:endParaRPr lang="de-CH" dirty="0"/>
           </a:p>
@@ -4337,7 +4443,7 @@
           <p:cNvPr id="3" name="Inhaltsplatzhalter 2">
             <a:extLst>
               <a:ext uri="{FF2B5EF4-FFF2-40B4-BE49-F238E27FC236}">
-                <a16:creationId xmlns:a16="http://schemas.microsoft.com/office/drawing/2014/main" id="{45FACC79-191B-119D-4036-802924DB76A4}"/>
+                <a16:creationId xmlns:a16="http://schemas.microsoft.com/office/drawing/2014/main" id="{2ACC9D9A-399F-CB94-B03E-2537D3174184}"/>
               </a:ext>
             </a:extLst>
           </p:cNvPr>
@@ -4353,36 +4459,7 @@
           <a:bodyPr/>
           <a:lstStyle/>
           <a:p>
-            <a:r>
-              <a:rPr lang="de-DE" dirty="0" err="1"/>
-              <a:t>Particle</a:t>
-            </a:r>
-            <a:r>
-              <a:rPr lang="de-DE" dirty="0"/>
-              <a:t> Mesh code</a:t>
-            </a:r>
-          </a:p>
-          <a:p>
-            <a:r>
-              <a:rPr lang="de-CH" dirty="0"/>
-              <a:t>Time </a:t>
-            </a:r>
-            <a:r>
-              <a:rPr lang="de-CH" dirty="0" err="1"/>
-              <a:t>integration</a:t>
-            </a:r>
-            <a:endParaRPr lang="de-CH" dirty="0"/>
-          </a:p>
-          <a:p>
-            <a:r>
-              <a:rPr lang="de-CH" dirty="0"/>
-              <a:t>Different </a:t>
-            </a:r>
-            <a:r>
-              <a:rPr lang="de-CH" dirty="0" err="1"/>
-              <a:t>checks</a:t>
-            </a:r>
-            <a:endParaRPr lang="de-CH" dirty="0"/>
+            <a:endParaRPr lang="de-CH"/>
           </a:p>
         </p:txBody>
       </p:sp>
@@ -4391,7 +4468,7 @@
           <p:cNvPr id="4" name="Fußzeilenplatzhalter 3">
             <a:extLst>
               <a:ext uri="{FF2B5EF4-FFF2-40B4-BE49-F238E27FC236}">
-                <a16:creationId xmlns:a16="http://schemas.microsoft.com/office/drawing/2014/main" id="{4CBE411E-D419-4E97-12DF-4FCD46213FD1}"/>
+                <a16:creationId xmlns:a16="http://schemas.microsoft.com/office/drawing/2014/main" id="{F7CC272D-6615-4EBD-8167-390D964CD05B}"/>
               </a:ext>
             </a:extLst>
           </p:cNvPr>
@@ -4419,7 +4496,7 @@
           <p:cNvPr id="5" name="Foliennummernplatzhalter 4">
             <a:extLst>
               <a:ext uri="{FF2B5EF4-FFF2-40B4-BE49-F238E27FC236}">
-                <a16:creationId xmlns:a16="http://schemas.microsoft.com/office/drawing/2014/main" id="{0E97FF82-EED6-F32D-27A8-F1360C95BA44}"/>
+                <a16:creationId xmlns:a16="http://schemas.microsoft.com/office/drawing/2014/main" id="{96A574D6-8010-7237-4B19-0E5785AC3497}"/>
               </a:ext>
             </a:extLst>
           </p:cNvPr>
@@ -4446,7 +4523,7 @@
     </p:spTree>
     <p:extLst>
       <p:ext uri="{BB962C8B-B14F-4D97-AF65-F5344CB8AC3E}">
-        <p14:creationId xmlns:p14="http://schemas.microsoft.com/office/powerpoint/2010/main" val="3228109496"/>
+        <p14:creationId xmlns:p14="http://schemas.microsoft.com/office/powerpoint/2010/main" val="3537959711"/>
       </p:ext>
     </p:extLst>
   </p:cSld>
@@ -4478,7 +4555,7 @@
           <p:cNvPr id="2" name="Titel 1">
             <a:extLst>
               <a:ext uri="{FF2B5EF4-FFF2-40B4-BE49-F238E27FC236}">
-                <a16:creationId xmlns:a16="http://schemas.microsoft.com/office/drawing/2014/main" id="{AEFAB5C2-9EA0-57CF-E008-96D3DD9CF81E}"/>
+                <a16:creationId xmlns:a16="http://schemas.microsoft.com/office/drawing/2014/main" id="{C703E5DC-2AF6-6DE0-E527-428B98CE8FE5}"/>
               </a:ext>
             </a:extLst>
           </p:cNvPr>
@@ -4496,10 +4573,70 @@
           <a:p>
             <a:r>
               <a:rPr lang="de-DE" dirty="0"/>
+              <a:t>Task 2 - Time Integrator and </a:t>
+            </a:r>
+            <a:r>
+              <a:rPr lang="de-DE" dirty="0" err="1"/>
+              <a:t>evolution</a:t>
+            </a:r>
+            <a:endParaRPr lang="de-CH" dirty="0"/>
+          </a:p>
+        </p:txBody>
+      </p:sp>
+      <p:sp>
+        <p:nvSpPr>
+          <p:cNvPr id="3" name="Inhaltsplatzhalter 2">
+            <a:extLst>
+              <a:ext uri="{FF2B5EF4-FFF2-40B4-BE49-F238E27FC236}">
+                <a16:creationId xmlns:a16="http://schemas.microsoft.com/office/drawing/2014/main" id="{45FACC79-191B-119D-4036-802924DB76A4}"/>
+              </a:ext>
+            </a:extLst>
+          </p:cNvPr>
+          <p:cNvSpPr>
+            <a:spLocks noGrp="1"/>
+          </p:cNvSpPr>
+          <p:nvPr>
+            <p:ph idx="1"/>
+          </p:nvPr>
+        </p:nvSpPr>
+        <p:spPr/>
+        <p:txBody>
+          <a:bodyPr/>
+          <a:lstStyle/>
+          <a:p>
+            <a:r>
+              <a:rPr lang="de-DE" dirty="0"/>
+              <a:t>Brute Force Implementation</a:t>
+            </a:r>
+          </a:p>
+          <a:p>
+            <a:r>
+              <a:rPr lang="de-DE" dirty="0" err="1"/>
+              <a:t>Particle</a:t>
+            </a:r>
+            <a:r>
+              <a:rPr lang="de-DE" dirty="0"/>
+              <a:t> Mesh code</a:t>
+            </a:r>
+          </a:p>
+          <a:p>
+            <a:r>
+              <a:rPr lang="de-CH" dirty="0"/>
+              <a:t>Time </a:t>
+            </a:r>
+            <a:r>
+              <a:rPr lang="de-CH" dirty="0" err="1"/>
+              <a:t>integration</a:t>
+            </a:r>
+            <a:endParaRPr lang="de-CH" dirty="0"/>
+          </a:p>
+          <a:p>
+            <a:r>
+              <a:rPr lang="de-CH" dirty="0"/>
               <a:t>Different </a:t>
             </a:r>
             <a:r>
-              <a:rPr lang="de-DE" dirty="0" err="1"/>
+              <a:rPr lang="de-CH" dirty="0" err="1"/>
               <a:t>checks</a:t>
             </a:r>
             <a:endParaRPr lang="de-CH" dirty="0"/>
@@ -4508,144 +4645,10 @@
       </p:sp>
       <p:sp>
         <p:nvSpPr>
-          <p:cNvPr id="3" name="Inhaltsplatzhalter 2">
-            <a:extLst>
-              <a:ext uri="{FF2B5EF4-FFF2-40B4-BE49-F238E27FC236}">
-                <a16:creationId xmlns:a16="http://schemas.microsoft.com/office/drawing/2014/main" id="{257823D2-3908-D78B-6BB3-9323BB88A2EA}"/>
-              </a:ext>
-            </a:extLst>
-          </p:cNvPr>
-          <p:cNvSpPr>
-            <a:spLocks noGrp="1"/>
-          </p:cNvSpPr>
-          <p:nvPr>
-            <p:ph idx="1"/>
-          </p:nvPr>
-        </p:nvSpPr>
-        <p:spPr/>
-        <p:txBody>
-          <a:bodyPr/>
-          <a:lstStyle/>
-          <a:p>
-            <a:r>
-              <a:rPr lang="de-DE" dirty="0"/>
-              <a:t>Density </a:t>
-            </a:r>
-            <a:r>
-              <a:rPr lang="de-DE" dirty="0" err="1"/>
-              <a:t>distribution</a:t>
-            </a:r>
-            <a:r>
-              <a:rPr lang="de-DE" dirty="0"/>
-              <a:t> check</a:t>
-            </a:r>
-          </a:p>
-          <a:p>
-            <a:r>
-              <a:rPr lang="de-CH" dirty="0"/>
-              <a:t>Constant </a:t>
-            </a:r>
-            <a:r>
-              <a:rPr lang="de-CH" dirty="0" err="1"/>
-              <a:t>energy</a:t>
-            </a:r>
-            <a:endParaRPr lang="de-CH" dirty="0"/>
-          </a:p>
-          <a:p>
-            <a:r>
-              <a:rPr lang="de-CH" dirty="0"/>
-              <a:t>Constant </a:t>
-            </a:r>
-            <a:r>
-              <a:rPr lang="de-CH" dirty="0" err="1"/>
-              <a:t>velocity</a:t>
-            </a:r>
-            <a:r>
-              <a:rPr lang="de-CH" dirty="0"/>
-              <a:t> (</a:t>
-            </a:r>
-            <a:r>
-              <a:rPr lang="de-CH" dirty="0" err="1"/>
-              <a:t>probably</a:t>
-            </a:r>
-            <a:r>
-              <a:rPr lang="de-CH" dirty="0"/>
-              <a:t> </a:t>
-            </a:r>
-            <a:r>
-              <a:rPr lang="de-CH" dirty="0" err="1"/>
-              <a:t>already</a:t>
-            </a:r>
-            <a:r>
-              <a:rPr lang="de-CH" dirty="0"/>
-              <a:t> </a:t>
-            </a:r>
-            <a:r>
-              <a:rPr lang="de-CH" dirty="0" err="1"/>
-              <a:t>constant</a:t>
-            </a:r>
-            <a:r>
-              <a:rPr lang="de-CH" dirty="0"/>
-              <a:t> </a:t>
-            </a:r>
-            <a:r>
-              <a:rPr lang="de-CH" dirty="0" err="1"/>
-              <a:t>when</a:t>
-            </a:r>
-            <a:r>
-              <a:rPr lang="de-CH" dirty="0"/>
-              <a:t> </a:t>
-            </a:r>
-            <a:r>
-              <a:rPr lang="de-CH" dirty="0" err="1"/>
-              <a:t>kinetic</a:t>
-            </a:r>
-            <a:r>
-              <a:rPr lang="de-CH" dirty="0"/>
-              <a:t> </a:t>
-            </a:r>
-            <a:r>
-              <a:rPr lang="de-CH" dirty="0" err="1"/>
-              <a:t>energy</a:t>
-            </a:r>
-            <a:r>
-              <a:rPr lang="de-CH" dirty="0"/>
-              <a:t> </a:t>
-            </a:r>
-            <a:r>
-              <a:rPr lang="de-CH" dirty="0" err="1"/>
-              <a:t>is</a:t>
-            </a:r>
-            <a:r>
-              <a:rPr lang="de-CH" dirty="0"/>
-              <a:t> </a:t>
-            </a:r>
-            <a:r>
-              <a:rPr lang="de-CH"/>
-              <a:t>constant)</a:t>
-            </a:r>
-            <a:endParaRPr lang="de-CH" dirty="0"/>
-          </a:p>
-          <a:p>
-            <a:r>
-              <a:rPr lang="de-CH" dirty="0"/>
-              <a:t>Constant mass</a:t>
-            </a:r>
-          </a:p>
-          <a:p>
-            <a:r>
-              <a:rPr lang="de-CH" dirty="0"/>
-              <a:t>????</a:t>
-            </a:r>
-          </a:p>
-        </p:txBody>
-      </p:sp>
-      <p:sp>
-        <p:nvSpPr>
           <p:cNvPr id="4" name="Fußzeilenplatzhalter 3">
             <a:extLst>
               <a:ext uri="{FF2B5EF4-FFF2-40B4-BE49-F238E27FC236}">
-                <a16:creationId xmlns:a16="http://schemas.microsoft.com/office/drawing/2014/main" id="{36CB85A3-9DF4-E604-790F-BA6AD7BDAC2B}"/>
+                <a16:creationId xmlns:a16="http://schemas.microsoft.com/office/drawing/2014/main" id="{4CBE411E-D419-4E97-12DF-4FCD46213FD1}"/>
               </a:ext>
             </a:extLst>
           </p:cNvPr>
@@ -4673,7 +4676,7 @@
           <p:cNvPr id="5" name="Foliennummernplatzhalter 4">
             <a:extLst>
               <a:ext uri="{FF2B5EF4-FFF2-40B4-BE49-F238E27FC236}">
-                <a16:creationId xmlns:a16="http://schemas.microsoft.com/office/drawing/2014/main" id="{BC86CCC3-F351-386F-1BD9-2EFD7F4CDB8C}"/>
+                <a16:creationId xmlns:a16="http://schemas.microsoft.com/office/drawing/2014/main" id="{0E97FF82-EED6-F32D-27A8-F1360C95BA44}"/>
               </a:ext>
             </a:extLst>
           </p:cNvPr>
@@ -4700,7 +4703,1087 @@
     </p:spTree>
     <p:extLst>
       <p:ext uri="{BB962C8B-B14F-4D97-AF65-F5344CB8AC3E}">
+        <p14:creationId xmlns:p14="http://schemas.microsoft.com/office/powerpoint/2010/main" val="3228109496"/>
+      </p:ext>
+    </p:extLst>
+  </p:cSld>
+  <p:clrMapOvr>
+    <a:masterClrMapping/>
+  </p:clrMapOvr>
+</p:sld>
+</file>
+
+<file path=ppt/slides/slide5.xml><?xml version="1.0" encoding="utf-8"?>
+<p:sld xmlns:a="http://schemas.openxmlformats.org/drawingml/2006/main" xmlns:r="http://schemas.openxmlformats.org/officeDocument/2006/relationships" xmlns:p="http://schemas.openxmlformats.org/presentationml/2006/main">
+  <p:cSld>
+    <p:spTree>
+      <p:nvGrpSpPr>
+        <p:cNvPr id="1" name=""/>
+        <p:cNvGrpSpPr/>
+        <p:nvPr/>
+      </p:nvGrpSpPr>
+      <p:grpSpPr>
+        <a:xfrm>
+          <a:off x="0" y="0"/>
+          <a:ext cx="0" cy="0"/>
+          <a:chOff x="0" y="0"/>
+          <a:chExt cx="0" cy="0"/>
+        </a:xfrm>
+      </p:grpSpPr>
+      <p:sp>
+        <p:nvSpPr>
+          <p:cNvPr id="2" name="Titel 1">
+            <a:extLst>
+              <a:ext uri="{FF2B5EF4-FFF2-40B4-BE49-F238E27FC236}">
+                <a16:creationId xmlns:a16="http://schemas.microsoft.com/office/drawing/2014/main" id="{AEFAB5C2-9EA0-57CF-E008-96D3DD9CF81E}"/>
+              </a:ext>
+            </a:extLst>
+          </p:cNvPr>
+          <p:cNvSpPr>
+            <a:spLocks noGrp="1"/>
+          </p:cNvSpPr>
+          <p:nvPr>
+            <p:ph type="title"/>
+          </p:nvPr>
+        </p:nvSpPr>
+        <p:spPr/>
+        <p:txBody>
+          <a:bodyPr/>
+          <a:lstStyle/>
+          <a:p>
+            <a:r>
+              <a:rPr lang="de-DE" dirty="0"/>
+              <a:t>Different </a:t>
+            </a:r>
+            <a:r>
+              <a:rPr lang="de-DE" dirty="0" err="1"/>
+              <a:t>checks</a:t>
+            </a:r>
+            <a:endParaRPr lang="de-CH" dirty="0"/>
+          </a:p>
+        </p:txBody>
+      </p:sp>
+      <p:sp>
+        <p:nvSpPr>
+          <p:cNvPr id="3" name="Inhaltsplatzhalter 2">
+            <a:extLst>
+              <a:ext uri="{FF2B5EF4-FFF2-40B4-BE49-F238E27FC236}">
+                <a16:creationId xmlns:a16="http://schemas.microsoft.com/office/drawing/2014/main" id="{257823D2-3908-D78B-6BB3-9323BB88A2EA}"/>
+              </a:ext>
+            </a:extLst>
+          </p:cNvPr>
+          <p:cNvSpPr>
+            <a:spLocks noGrp="1"/>
+          </p:cNvSpPr>
+          <p:nvPr>
+            <p:ph idx="1"/>
+          </p:nvPr>
+        </p:nvSpPr>
+        <p:spPr/>
+        <p:txBody>
+          <a:bodyPr/>
+          <a:lstStyle/>
+          <a:p>
+            <a:r>
+              <a:rPr lang="de-DE" dirty="0"/>
+              <a:t>Density </a:t>
+            </a:r>
+            <a:r>
+              <a:rPr lang="de-DE" dirty="0" err="1"/>
+              <a:t>distribution</a:t>
+            </a:r>
+            <a:r>
+              <a:rPr lang="de-DE" dirty="0"/>
+              <a:t> check</a:t>
+            </a:r>
+          </a:p>
+          <a:p>
+            <a:r>
+              <a:rPr lang="de-CH" dirty="0"/>
+              <a:t>Constant </a:t>
+            </a:r>
+            <a:r>
+              <a:rPr lang="de-CH" dirty="0" err="1"/>
+              <a:t>energy</a:t>
+            </a:r>
+            <a:endParaRPr lang="de-CH" dirty="0"/>
+          </a:p>
+          <a:p>
+            <a:r>
+              <a:rPr lang="de-CH" dirty="0"/>
+              <a:t>Constant </a:t>
+            </a:r>
+            <a:r>
+              <a:rPr lang="de-CH" dirty="0" err="1"/>
+              <a:t>velocity</a:t>
+            </a:r>
+            <a:r>
+              <a:rPr lang="de-CH" dirty="0"/>
+              <a:t> (</a:t>
+            </a:r>
+            <a:r>
+              <a:rPr lang="de-CH" dirty="0" err="1"/>
+              <a:t>probably</a:t>
+            </a:r>
+            <a:r>
+              <a:rPr lang="de-CH" dirty="0"/>
+              <a:t> </a:t>
+            </a:r>
+            <a:r>
+              <a:rPr lang="de-CH" dirty="0" err="1"/>
+              <a:t>already</a:t>
+            </a:r>
+            <a:r>
+              <a:rPr lang="de-CH" dirty="0"/>
+              <a:t> </a:t>
+            </a:r>
+            <a:r>
+              <a:rPr lang="de-CH" dirty="0" err="1"/>
+              <a:t>constant</a:t>
+            </a:r>
+            <a:r>
+              <a:rPr lang="de-CH" dirty="0"/>
+              <a:t> </a:t>
+            </a:r>
+            <a:r>
+              <a:rPr lang="de-CH" dirty="0" err="1"/>
+              <a:t>when</a:t>
+            </a:r>
+            <a:r>
+              <a:rPr lang="de-CH" dirty="0"/>
+              <a:t> </a:t>
+            </a:r>
+            <a:r>
+              <a:rPr lang="de-CH" dirty="0" err="1"/>
+              <a:t>kinetic</a:t>
+            </a:r>
+            <a:r>
+              <a:rPr lang="de-CH" dirty="0"/>
+              <a:t> </a:t>
+            </a:r>
+            <a:r>
+              <a:rPr lang="de-CH" dirty="0" err="1"/>
+              <a:t>energy</a:t>
+            </a:r>
+            <a:r>
+              <a:rPr lang="de-CH" dirty="0"/>
+              <a:t> </a:t>
+            </a:r>
+            <a:r>
+              <a:rPr lang="de-CH" dirty="0" err="1"/>
+              <a:t>is</a:t>
+            </a:r>
+            <a:r>
+              <a:rPr lang="de-CH" dirty="0"/>
+              <a:t> </a:t>
+            </a:r>
+            <a:r>
+              <a:rPr lang="de-CH" dirty="0" err="1"/>
+              <a:t>constant</a:t>
+            </a:r>
+            <a:r>
+              <a:rPr lang="de-CH" dirty="0"/>
+              <a:t>)</a:t>
+            </a:r>
+          </a:p>
+          <a:p>
+            <a:r>
+              <a:rPr lang="de-CH" dirty="0"/>
+              <a:t>Constant mass</a:t>
+            </a:r>
+          </a:p>
+          <a:p>
+            <a:r>
+              <a:rPr lang="de-CH" dirty="0"/>
+              <a:t>????</a:t>
+            </a:r>
+          </a:p>
+        </p:txBody>
+      </p:sp>
+      <p:sp>
+        <p:nvSpPr>
+          <p:cNvPr id="4" name="Fußzeilenplatzhalter 3">
+            <a:extLst>
+              <a:ext uri="{FF2B5EF4-FFF2-40B4-BE49-F238E27FC236}">
+                <a16:creationId xmlns:a16="http://schemas.microsoft.com/office/drawing/2014/main" id="{36CB85A3-9DF4-E604-790F-BA6AD7BDAC2B}"/>
+              </a:ext>
+            </a:extLst>
+          </p:cNvPr>
+          <p:cNvSpPr>
+            <a:spLocks noGrp="1"/>
+          </p:cNvSpPr>
+          <p:nvPr>
+            <p:ph type="ftr" sz="quarter" idx="11"/>
+          </p:nvPr>
+        </p:nvSpPr>
+        <p:spPr/>
+        <p:txBody>
+          <a:bodyPr/>
+          <a:lstStyle/>
+          <a:p>
+            <a:r>
+              <a:rPr lang="de-CH"/>
+              <a:t>Diego Söldi</a:t>
+            </a:r>
+          </a:p>
+        </p:txBody>
+      </p:sp>
+      <p:sp>
+        <p:nvSpPr>
+          <p:cNvPr id="5" name="Foliennummernplatzhalter 4">
+            <a:extLst>
+              <a:ext uri="{FF2B5EF4-FFF2-40B4-BE49-F238E27FC236}">
+                <a16:creationId xmlns:a16="http://schemas.microsoft.com/office/drawing/2014/main" id="{BC86CCC3-F351-386F-1BD9-2EFD7F4CDB8C}"/>
+              </a:ext>
+            </a:extLst>
+          </p:cNvPr>
+          <p:cNvSpPr>
+            <a:spLocks noGrp="1"/>
+          </p:cNvSpPr>
+          <p:nvPr>
+            <p:ph type="sldNum" sz="quarter" idx="12"/>
+          </p:nvPr>
+        </p:nvSpPr>
+        <p:spPr/>
+        <p:txBody>
+          <a:bodyPr/>
+          <a:lstStyle/>
+          <a:p>
+            <a:fld id="{79D1B373-AB7F-4F57-AEBA-BF7EB707F53C}" type="slidenum">
+              <a:rPr lang="de-CH" smtClean="0"/>
+              <a:t>5</a:t>
+            </a:fld>
+            <a:endParaRPr lang="de-CH"/>
+          </a:p>
+        </p:txBody>
+      </p:sp>
+    </p:spTree>
+    <p:extLst>
+      <p:ext uri="{BB962C8B-B14F-4D97-AF65-F5344CB8AC3E}">
         <p14:creationId xmlns:p14="http://schemas.microsoft.com/office/powerpoint/2010/main" val="2404851927"/>
+      </p:ext>
+    </p:extLst>
+  </p:cSld>
+  <p:clrMapOvr>
+    <a:masterClrMapping/>
+  </p:clrMapOvr>
+</p:sld>
+</file>
+
+<file path=ppt/slides/slide6.xml><?xml version="1.0" encoding="utf-8"?>
+<p:sld xmlns:a="http://schemas.openxmlformats.org/drawingml/2006/main" xmlns:r="http://schemas.openxmlformats.org/officeDocument/2006/relationships" xmlns:p="http://schemas.openxmlformats.org/presentationml/2006/main" show="0">
+  <p:cSld>
+    <p:spTree>
+      <p:nvGrpSpPr>
+        <p:cNvPr id="1" name=""/>
+        <p:cNvGrpSpPr/>
+        <p:nvPr/>
+      </p:nvGrpSpPr>
+      <p:grpSpPr>
+        <a:xfrm>
+          <a:off x="0" y="0"/>
+          <a:ext cx="0" cy="0"/>
+          <a:chOff x="0" y="0"/>
+          <a:chExt cx="0" cy="0"/>
+        </a:xfrm>
+      </p:grpSpPr>
+      <p:sp>
+        <p:nvSpPr>
+          <p:cNvPr id="2" name="Titel 1">
+            <a:extLst>
+              <a:ext uri="{FF2B5EF4-FFF2-40B4-BE49-F238E27FC236}">
+                <a16:creationId xmlns:a16="http://schemas.microsoft.com/office/drawing/2014/main" id="{AAEC1150-26B3-CCE0-11A1-3B5A92A302C4}"/>
+              </a:ext>
+            </a:extLst>
+          </p:cNvPr>
+          <p:cNvSpPr>
+            <a:spLocks noGrp="1"/>
+          </p:cNvSpPr>
+          <p:nvPr>
+            <p:ph type="title"/>
+          </p:nvPr>
+        </p:nvSpPr>
+        <p:spPr/>
+        <p:txBody>
+          <a:bodyPr>
+            <a:normAutofit/>
+          </a:bodyPr>
+          <a:lstStyle/>
+          <a:p>
+            <a:r>
+              <a:rPr lang="de-DE" dirty="0" err="1"/>
+              <a:t>To</a:t>
+            </a:r>
+            <a:r>
+              <a:rPr lang="de-DE" dirty="0"/>
+              <a:t> Do Single </a:t>
+            </a:r>
+            <a:r>
+              <a:rPr lang="de-DE" dirty="0" err="1"/>
+              <a:t>step</a:t>
+            </a:r>
+            <a:r>
+              <a:rPr lang="de-DE" dirty="0"/>
+              <a:t> </a:t>
+            </a:r>
+            <a:r>
+              <a:rPr lang="de-DE" dirty="0" err="1"/>
+              <a:t>particle</a:t>
+            </a:r>
+            <a:r>
+              <a:rPr lang="de-DE" dirty="0"/>
+              <a:t> </a:t>
+            </a:r>
+            <a:r>
+              <a:rPr lang="de-DE" dirty="0" err="1"/>
+              <a:t>mesh</a:t>
+            </a:r>
+            <a:endParaRPr lang="de-CH" dirty="0"/>
+          </a:p>
+        </p:txBody>
+      </p:sp>
+      <p:sp>
+        <p:nvSpPr>
+          <p:cNvPr id="3" name="Inhaltsplatzhalter 2">
+            <a:extLst>
+              <a:ext uri="{FF2B5EF4-FFF2-40B4-BE49-F238E27FC236}">
+                <a16:creationId xmlns:a16="http://schemas.microsoft.com/office/drawing/2014/main" id="{1A2A4AF0-4310-3FB5-1104-99A8D907DF5C}"/>
+              </a:ext>
+            </a:extLst>
+          </p:cNvPr>
+          <p:cNvSpPr>
+            <a:spLocks noGrp="1"/>
+          </p:cNvSpPr>
+          <p:nvPr>
+            <p:ph idx="1"/>
+          </p:nvPr>
+        </p:nvSpPr>
+        <p:spPr/>
+        <p:txBody>
+          <a:bodyPr/>
+          <a:lstStyle/>
+          <a:p>
+            <a:r>
+              <a:rPr lang="de-DE" dirty="0" err="1"/>
+              <a:t>Compare</a:t>
+            </a:r>
+            <a:r>
+              <a:rPr lang="de-DE" dirty="0"/>
+              <a:t> </a:t>
+            </a:r>
+            <a:r>
+              <a:rPr lang="de-DE" dirty="0" err="1"/>
+              <a:t>particle</a:t>
+            </a:r>
+            <a:r>
+              <a:rPr lang="de-DE" dirty="0"/>
+              <a:t> </a:t>
+            </a:r>
+            <a:r>
+              <a:rPr lang="de-DE" dirty="0" err="1"/>
+              <a:t>mesh</a:t>
+            </a:r>
+            <a:r>
+              <a:rPr lang="de-DE" dirty="0"/>
+              <a:t> </a:t>
+            </a:r>
+            <a:r>
+              <a:rPr lang="de-DE" dirty="0" err="1"/>
+              <a:t>forces</a:t>
+            </a:r>
+            <a:r>
+              <a:rPr lang="de-DE" dirty="0"/>
+              <a:t> </a:t>
+            </a:r>
+            <a:r>
+              <a:rPr lang="de-DE" dirty="0" err="1"/>
+              <a:t>to</a:t>
+            </a:r>
+            <a:r>
+              <a:rPr lang="de-DE" dirty="0"/>
+              <a:t> </a:t>
+            </a:r>
+            <a:r>
+              <a:rPr lang="de-DE" dirty="0" err="1"/>
+              <a:t>direct</a:t>
+            </a:r>
+            <a:r>
+              <a:rPr lang="de-DE" dirty="0"/>
+              <a:t> </a:t>
+            </a:r>
+            <a:r>
+              <a:rPr lang="de-DE" dirty="0" err="1"/>
+              <a:t>summation</a:t>
+            </a:r>
+            <a:r>
+              <a:rPr lang="de-DE" dirty="0"/>
+              <a:t> </a:t>
+            </a:r>
+            <a:r>
+              <a:rPr lang="de-DE" dirty="0" err="1"/>
+              <a:t>results</a:t>
+            </a:r>
+            <a:endParaRPr lang="de-DE" dirty="0"/>
+          </a:p>
+          <a:p>
+            <a:r>
+              <a:rPr lang="de-CH" dirty="0" err="1"/>
+              <a:t>Calculate</a:t>
+            </a:r>
+            <a:r>
+              <a:rPr lang="de-CH" dirty="0"/>
+              <a:t> </a:t>
+            </a:r>
+            <a:r>
+              <a:rPr lang="de-CH" dirty="0" err="1"/>
+              <a:t>accuracies</a:t>
+            </a:r>
+            <a:r>
+              <a:rPr lang="de-CH" dirty="0"/>
+              <a:t> </a:t>
+            </a:r>
+            <a:r>
+              <a:rPr lang="de-CH" dirty="0" err="1"/>
+              <a:t>between</a:t>
+            </a:r>
+            <a:r>
+              <a:rPr lang="de-CH" dirty="0"/>
+              <a:t> </a:t>
+            </a:r>
+            <a:r>
+              <a:rPr lang="de-CH" dirty="0" err="1"/>
+              <a:t>particle</a:t>
+            </a:r>
+            <a:r>
+              <a:rPr lang="de-CH" dirty="0"/>
+              <a:t> </a:t>
+            </a:r>
+            <a:r>
+              <a:rPr lang="de-CH" dirty="0" err="1"/>
+              <a:t>mesh</a:t>
+            </a:r>
+            <a:r>
+              <a:rPr lang="de-CH" dirty="0"/>
+              <a:t> and </a:t>
+            </a:r>
+            <a:r>
+              <a:rPr lang="de-CH" dirty="0" err="1"/>
+              <a:t>direct</a:t>
+            </a:r>
+            <a:r>
+              <a:rPr lang="de-CH" dirty="0"/>
+              <a:t> </a:t>
+            </a:r>
+            <a:r>
+              <a:rPr lang="de-CH" dirty="0" err="1"/>
+              <a:t>summation</a:t>
+            </a:r>
+            <a:r>
+              <a:rPr lang="de-CH" dirty="0"/>
+              <a:t>, </a:t>
+            </a:r>
+            <a:r>
+              <a:rPr lang="de-CH" dirty="0" err="1"/>
+              <a:t>compare</a:t>
+            </a:r>
+            <a:r>
+              <a:rPr lang="de-CH" dirty="0"/>
+              <a:t> </a:t>
+            </a:r>
+            <a:r>
+              <a:rPr lang="de-CH" dirty="0" err="1"/>
+              <a:t>computational</a:t>
+            </a:r>
+            <a:r>
+              <a:rPr lang="de-CH" dirty="0"/>
+              <a:t> </a:t>
+            </a:r>
+            <a:r>
+              <a:rPr lang="de-CH" dirty="0" err="1"/>
+              <a:t>costs</a:t>
+            </a:r>
+            <a:endParaRPr lang="de-CH" dirty="0"/>
+          </a:p>
+          <a:p>
+            <a:r>
+              <a:rPr lang="de-CH" dirty="0"/>
+              <a:t>Try different </a:t>
+            </a:r>
+            <a:r>
+              <a:rPr lang="de-CH" dirty="0" err="1"/>
+              <a:t>softenings</a:t>
+            </a:r>
+            <a:endParaRPr lang="de-CH" dirty="0"/>
+          </a:p>
+          <a:p>
+            <a:r>
+              <a:rPr lang="de-CH" dirty="0"/>
+              <a:t>Try different </a:t>
+            </a:r>
+            <a:r>
+              <a:rPr lang="de-CH" dirty="0" err="1"/>
+              <a:t>grid</a:t>
+            </a:r>
+            <a:r>
+              <a:rPr lang="de-CH" dirty="0"/>
+              <a:t> </a:t>
+            </a:r>
+            <a:r>
+              <a:rPr lang="de-CH" dirty="0" err="1"/>
+              <a:t>spacings</a:t>
+            </a:r>
+            <a:endParaRPr lang="de-CH" dirty="0"/>
+          </a:p>
+          <a:p>
+            <a:endParaRPr lang="de-CH" dirty="0"/>
+          </a:p>
+        </p:txBody>
+      </p:sp>
+      <p:sp>
+        <p:nvSpPr>
+          <p:cNvPr id="4" name="Fußzeilenplatzhalter 3">
+            <a:extLst>
+              <a:ext uri="{FF2B5EF4-FFF2-40B4-BE49-F238E27FC236}">
+                <a16:creationId xmlns:a16="http://schemas.microsoft.com/office/drawing/2014/main" id="{DD2BC505-3DBA-5892-A0EA-B26FE18DF1DB}"/>
+              </a:ext>
+            </a:extLst>
+          </p:cNvPr>
+          <p:cNvSpPr>
+            <a:spLocks noGrp="1"/>
+          </p:cNvSpPr>
+          <p:nvPr>
+            <p:ph type="ftr" sz="quarter" idx="11"/>
+          </p:nvPr>
+        </p:nvSpPr>
+        <p:spPr/>
+        <p:txBody>
+          <a:bodyPr/>
+          <a:lstStyle/>
+          <a:p>
+            <a:r>
+              <a:rPr lang="de-CH"/>
+              <a:t>Diego Söldi</a:t>
+            </a:r>
+          </a:p>
+        </p:txBody>
+      </p:sp>
+      <p:sp>
+        <p:nvSpPr>
+          <p:cNvPr id="5" name="Foliennummernplatzhalter 4">
+            <a:extLst>
+              <a:ext uri="{FF2B5EF4-FFF2-40B4-BE49-F238E27FC236}">
+                <a16:creationId xmlns:a16="http://schemas.microsoft.com/office/drawing/2014/main" id="{67B88D29-8575-FF13-6BE2-FF127AEFBF4C}"/>
+              </a:ext>
+            </a:extLst>
+          </p:cNvPr>
+          <p:cNvSpPr>
+            <a:spLocks noGrp="1"/>
+          </p:cNvSpPr>
+          <p:nvPr>
+            <p:ph type="sldNum" sz="quarter" idx="12"/>
+          </p:nvPr>
+        </p:nvSpPr>
+        <p:spPr/>
+        <p:txBody>
+          <a:bodyPr/>
+          <a:lstStyle/>
+          <a:p>
+            <a:fld id="{79D1B373-AB7F-4F57-AEBA-BF7EB707F53C}" type="slidenum">
+              <a:rPr lang="de-CH" smtClean="0"/>
+              <a:t>6</a:t>
+            </a:fld>
+            <a:endParaRPr lang="de-CH"/>
+          </a:p>
+        </p:txBody>
+      </p:sp>
+    </p:spTree>
+    <p:extLst>
+      <p:ext uri="{BB962C8B-B14F-4D97-AF65-F5344CB8AC3E}">
+        <p14:creationId xmlns:p14="http://schemas.microsoft.com/office/powerpoint/2010/main" val="2075024410"/>
+      </p:ext>
+    </p:extLst>
+  </p:cSld>
+  <p:clrMapOvr>
+    <a:masterClrMapping/>
+  </p:clrMapOvr>
+</p:sld>
+</file>
+
+<file path=ppt/slides/slide7.xml><?xml version="1.0" encoding="utf-8"?>
+<p:sld xmlns:a="http://schemas.openxmlformats.org/drawingml/2006/main" xmlns:r="http://schemas.openxmlformats.org/officeDocument/2006/relationships" xmlns:p="http://schemas.openxmlformats.org/presentationml/2006/main" show="0">
+  <p:cSld>
+    <p:spTree>
+      <p:nvGrpSpPr>
+        <p:cNvPr id="1" name="">
+          <a:extLst>
+            <a:ext uri="{FF2B5EF4-FFF2-40B4-BE49-F238E27FC236}">
+              <a16:creationId xmlns:a16="http://schemas.microsoft.com/office/drawing/2014/main" id="{3841EF2A-659F-D6CA-4066-E75FD7D12D81}"/>
+            </a:ext>
+          </a:extLst>
+        </p:cNvPr>
+        <p:cNvGrpSpPr/>
+        <p:nvPr/>
+      </p:nvGrpSpPr>
+      <p:grpSpPr>
+        <a:xfrm>
+          <a:off x="0" y="0"/>
+          <a:ext cx="0" cy="0"/>
+          <a:chOff x="0" y="0"/>
+          <a:chExt cx="0" cy="0"/>
+        </a:xfrm>
+      </p:grpSpPr>
+      <p:sp>
+        <p:nvSpPr>
+          <p:cNvPr id="2" name="Titel 1">
+            <a:extLst>
+              <a:ext uri="{FF2B5EF4-FFF2-40B4-BE49-F238E27FC236}">
+                <a16:creationId xmlns:a16="http://schemas.microsoft.com/office/drawing/2014/main" id="{7AAB86AA-B3BE-3132-E482-860F90ED34DB}"/>
+              </a:ext>
+            </a:extLst>
+          </p:cNvPr>
+          <p:cNvSpPr>
+            <a:spLocks noGrp="1"/>
+          </p:cNvSpPr>
+          <p:nvPr>
+            <p:ph type="title"/>
+          </p:nvPr>
+        </p:nvSpPr>
+        <p:spPr/>
+        <p:txBody>
+          <a:bodyPr>
+            <a:normAutofit/>
+          </a:bodyPr>
+          <a:lstStyle/>
+          <a:p>
+            <a:r>
+              <a:rPr lang="de-DE" dirty="0" err="1"/>
+              <a:t>To</a:t>
+            </a:r>
+            <a:r>
+              <a:rPr lang="de-DE" dirty="0"/>
+              <a:t> Do Integration </a:t>
+            </a:r>
+            <a:r>
+              <a:rPr lang="de-DE" dirty="0" err="1"/>
+              <a:t>brute</a:t>
+            </a:r>
+            <a:r>
+              <a:rPr lang="de-DE" dirty="0"/>
+              <a:t> </a:t>
+            </a:r>
+            <a:r>
+              <a:rPr lang="de-DE" dirty="0" err="1"/>
+              <a:t>force</a:t>
+            </a:r>
+            <a:endParaRPr lang="de-CH" dirty="0"/>
+          </a:p>
+        </p:txBody>
+      </p:sp>
+      <p:sp>
+        <p:nvSpPr>
+          <p:cNvPr id="3" name="Inhaltsplatzhalter 2">
+            <a:extLst>
+              <a:ext uri="{FF2B5EF4-FFF2-40B4-BE49-F238E27FC236}">
+                <a16:creationId xmlns:a16="http://schemas.microsoft.com/office/drawing/2014/main" id="{D3594631-2842-0B40-A0B1-9187BF7AC3BB}"/>
+              </a:ext>
+            </a:extLst>
+          </p:cNvPr>
+          <p:cNvSpPr>
+            <a:spLocks noGrp="1"/>
+          </p:cNvSpPr>
+          <p:nvPr>
+            <p:ph idx="1"/>
+          </p:nvPr>
+        </p:nvSpPr>
+        <p:spPr/>
+        <p:txBody>
+          <a:bodyPr/>
+          <a:lstStyle/>
+          <a:p>
+            <a:r>
+              <a:rPr lang="de-DE" dirty="0" err="1"/>
+              <a:t>Verify</a:t>
+            </a:r>
+            <a:r>
+              <a:rPr lang="de-DE" dirty="0"/>
+              <a:t> </a:t>
+            </a:r>
+            <a:r>
+              <a:rPr lang="de-DE" dirty="0" err="1"/>
+              <a:t>stability</a:t>
+            </a:r>
+            <a:endParaRPr lang="de-DE" dirty="0"/>
+          </a:p>
+          <a:p>
+            <a:r>
+              <a:rPr lang="de-DE" dirty="0"/>
+              <a:t>Try different </a:t>
+            </a:r>
+            <a:r>
+              <a:rPr lang="de-DE" dirty="0" err="1"/>
+              <a:t>softenings</a:t>
+            </a:r>
+            <a:endParaRPr lang="de-DE" dirty="0"/>
+          </a:p>
+          <a:p>
+            <a:r>
+              <a:rPr lang="de-DE" dirty="0"/>
+              <a:t>Try different </a:t>
+            </a:r>
+            <a:r>
+              <a:rPr lang="de-DE" dirty="0" err="1"/>
+              <a:t>timesteps</a:t>
+            </a:r>
+            <a:endParaRPr lang="de-DE" dirty="0"/>
+          </a:p>
+          <a:p>
+            <a:endParaRPr lang="de-CH" dirty="0"/>
+          </a:p>
+          <a:p>
+            <a:endParaRPr lang="de-CH" dirty="0"/>
+          </a:p>
+        </p:txBody>
+      </p:sp>
+      <p:sp>
+        <p:nvSpPr>
+          <p:cNvPr id="4" name="Fußzeilenplatzhalter 3">
+            <a:extLst>
+              <a:ext uri="{FF2B5EF4-FFF2-40B4-BE49-F238E27FC236}">
+                <a16:creationId xmlns:a16="http://schemas.microsoft.com/office/drawing/2014/main" id="{F08F2FCC-7E20-2DFD-20CD-DFAD22A41BE4}"/>
+              </a:ext>
+            </a:extLst>
+          </p:cNvPr>
+          <p:cNvSpPr>
+            <a:spLocks noGrp="1"/>
+          </p:cNvSpPr>
+          <p:nvPr>
+            <p:ph type="ftr" sz="quarter" idx="11"/>
+          </p:nvPr>
+        </p:nvSpPr>
+        <p:spPr/>
+        <p:txBody>
+          <a:bodyPr/>
+          <a:lstStyle/>
+          <a:p>
+            <a:r>
+              <a:rPr lang="de-CH"/>
+              <a:t>Diego Söldi</a:t>
+            </a:r>
+          </a:p>
+        </p:txBody>
+      </p:sp>
+      <p:sp>
+        <p:nvSpPr>
+          <p:cNvPr id="5" name="Foliennummernplatzhalter 4">
+            <a:extLst>
+              <a:ext uri="{FF2B5EF4-FFF2-40B4-BE49-F238E27FC236}">
+                <a16:creationId xmlns:a16="http://schemas.microsoft.com/office/drawing/2014/main" id="{CC5226E8-34E1-A420-AB08-313A4B45DF2E}"/>
+              </a:ext>
+            </a:extLst>
+          </p:cNvPr>
+          <p:cNvSpPr>
+            <a:spLocks noGrp="1"/>
+          </p:cNvSpPr>
+          <p:nvPr>
+            <p:ph type="sldNum" sz="quarter" idx="12"/>
+          </p:nvPr>
+        </p:nvSpPr>
+        <p:spPr/>
+        <p:txBody>
+          <a:bodyPr/>
+          <a:lstStyle/>
+          <a:p>
+            <a:fld id="{79D1B373-AB7F-4F57-AEBA-BF7EB707F53C}" type="slidenum">
+              <a:rPr lang="de-CH" smtClean="0"/>
+              <a:t>7</a:t>
+            </a:fld>
+            <a:endParaRPr lang="de-CH"/>
+          </a:p>
+        </p:txBody>
+      </p:sp>
+    </p:spTree>
+    <p:extLst>
+      <p:ext uri="{BB962C8B-B14F-4D97-AF65-F5344CB8AC3E}">
+        <p14:creationId xmlns:p14="http://schemas.microsoft.com/office/powerpoint/2010/main" val="4010987809"/>
+      </p:ext>
+    </p:extLst>
+  </p:cSld>
+  <p:clrMapOvr>
+    <a:masterClrMapping/>
+  </p:clrMapOvr>
+</p:sld>
+</file>
+
+<file path=ppt/slides/slide8.xml><?xml version="1.0" encoding="utf-8"?>
+<p:sld xmlns:a="http://schemas.openxmlformats.org/drawingml/2006/main" xmlns:r="http://schemas.openxmlformats.org/officeDocument/2006/relationships" xmlns:p="http://schemas.openxmlformats.org/presentationml/2006/main" show="0">
+  <p:cSld>
+    <p:spTree>
+      <p:nvGrpSpPr>
+        <p:cNvPr id="1" name="">
+          <a:extLst>
+            <a:ext uri="{FF2B5EF4-FFF2-40B4-BE49-F238E27FC236}">
+              <a16:creationId xmlns:a16="http://schemas.microsoft.com/office/drawing/2014/main" id="{21A4BDCF-59B6-EDD5-E941-C3F1AA947F1C}"/>
+            </a:ext>
+          </a:extLst>
+        </p:cNvPr>
+        <p:cNvGrpSpPr/>
+        <p:nvPr/>
+      </p:nvGrpSpPr>
+      <p:grpSpPr>
+        <a:xfrm>
+          <a:off x="0" y="0"/>
+          <a:ext cx="0" cy="0"/>
+          <a:chOff x="0" y="0"/>
+          <a:chExt cx="0" cy="0"/>
+        </a:xfrm>
+      </p:grpSpPr>
+      <p:sp>
+        <p:nvSpPr>
+          <p:cNvPr id="2" name="Titel 1">
+            <a:extLst>
+              <a:ext uri="{FF2B5EF4-FFF2-40B4-BE49-F238E27FC236}">
+                <a16:creationId xmlns:a16="http://schemas.microsoft.com/office/drawing/2014/main" id="{F993A75E-75C7-3FB9-8C74-AAD87356867C}"/>
+              </a:ext>
+            </a:extLst>
+          </p:cNvPr>
+          <p:cNvSpPr>
+            <a:spLocks noGrp="1"/>
+          </p:cNvSpPr>
+          <p:nvPr>
+            <p:ph type="title"/>
+          </p:nvPr>
+        </p:nvSpPr>
+        <p:spPr/>
+        <p:txBody>
+          <a:bodyPr>
+            <a:normAutofit/>
+          </a:bodyPr>
+          <a:lstStyle/>
+          <a:p>
+            <a:r>
+              <a:rPr lang="de-DE" dirty="0" err="1"/>
+              <a:t>To</a:t>
+            </a:r>
+            <a:r>
+              <a:rPr lang="de-DE" dirty="0"/>
+              <a:t> Do </a:t>
+            </a:r>
+            <a:r>
+              <a:rPr lang="de-DE" dirty="0" err="1"/>
+              <a:t>full</a:t>
+            </a:r>
+            <a:r>
+              <a:rPr lang="de-DE" dirty="0"/>
+              <a:t> PM Solver</a:t>
+            </a:r>
+            <a:endParaRPr lang="de-CH" dirty="0"/>
+          </a:p>
+        </p:txBody>
+      </p:sp>
+      <p:sp>
+        <p:nvSpPr>
+          <p:cNvPr id="3" name="Inhaltsplatzhalter 2">
+            <a:extLst>
+              <a:ext uri="{FF2B5EF4-FFF2-40B4-BE49-F238E27FC236}">
+                <a16:creationId xmlns:a16="http://schemas.microsoft.com/office/drawing/2014/main" id="{C418CF10-EC3D-94A3-9152-1EC15A4DCE8E}"/>
+              </a:ext>
+            </a:extLst>
+          </p:cNvPr>
+          <p:cNvSpPr>
+            <a:spLocks noGrp="1"/>
+          </p:cNvSpPr>
+          <p:nvPr>
+            <p:ph idx="1"/>
+          </p:nvPr>
+        </p:nvSpPr>
+        <p:spPr/>
+        <p:txBody>
+          <a:bodyPr/>
+          <a:lstStyle/>
+          <a:p>
+            <a:r>
+              <a:rPr lang="de-DE" dirty="0"/>
+              <a:t>Find out </a:t>
+            </a:r>
+            <a:r>
+              <a:rPr lang="de-DE" dirty="0" err="1"/>
+              <a:t>why</a:t>
+            </a:r>
+            <a:r>
+              <a:rPr lang="de-DE" dirty="0"/>
+              <a:t> </a:t>
+            </a:r>
+            <a:r>
+              <a:rPr lang="de-DE" dirty="0" err="1"/>
+              <a:t>disk</a:t>
+            </a:r>
+            <a:r>
+              <a:rPr lang="de-DE" dirty="0"/>
+              <a:t> </a:t>
+            </a:r>
+            <a:r>
+              <a:rPr lang="de-DE" dirty="0" err="1"/>
+              <a:t>is</a:t>
+            </a:r>
+            <a:r>
+              <a:rPr lang="de-DE" dirty="0"/>
+              <a:t> not in </a:t>
+            </a:r>
+            <a:r>
+              <a:rPr lang="de-DE" dirty="0" err="1"/>
+              <a:t>equilibrium</a:t>
+            </a:r>
+            <a:endParaRPr lang="de-DE" dirty="0"/>
+          </a:p>
+          <a:p>
+            <a:r>
+              <a:rPr lang="de-DE" dirty="0"/>
+              <a:t>Try different </a:t>
+            </a:r>
+            <a:r>
+              <a:rPr lang="de-DE" dirty="0" err="1"/>
+              <a:t>grid</a:t>
+            </a:r>
+            <a:r>
+              <a:rPr lang="de-DE" dirty="0"/>
+              <a:t> </a:t>
+            </a:r>
+            <a:r>
+              <a:rPr lang="de-DE" dirty="0" err="1"/>
+              <a:t>spacings</a:t>
+            </a:r>
+            <a:endParaRPr lang="de-DE" dirty="0"/>
+          </a:p>
+          <a:p>
+            <a:r>
+              <a:rPr lang="de-DE" dirty="0"/>
+              <a:t>Try different </a:t>
+            </a:r>
+            <a:r>
+              <a:rPr lang="de-DE" dirty="0" err="1"/>
+              <a:t>softenings</a:t>
+            </a:r>
+            <a:endParaRPr lang="de-DE" dirty="0"/>
+          </a:p>
+          <a:p>
+            <a:r>
+              <a:rPr lang="de-DE" dirty="0" err="1"/>
+              <a:t>Adjust</a:t>
+            </a:r>
+            <a:r>
+              <a:rPr lang="de-DE" dirty="0"/>
+              <a:t> initial </a:t>
+            </a:r>
+            <a:r>
+              <a:rPr lang="de-DE" dirty="0" err="1"/>
+              <a:t>conditions</a:t>
+            </a:r>
+            <a:r>
+              <a:rPr lang="de-DE" dirty="0"/>
+              <a:t> </a:t>
+            </a:r>
+            <a:r>
+              <a:rPr lang="de-DE" dirty="0" err="1"/>
+              <a:t>to</a:t>
+            </a:r>
+            <a:r>
+              <a:rPr lang="de-DE" dirty="0"/>
+              <a:t> </a:t>
+            </a:r>
+            <a:r>
+              <a:rPr lang="de-DE" dirty="0" err="1"/>
+              <a:t>be</a:t>
+            </a:r>
+            <a:r>
+              <a:rPr lang="de-DE" dirty="0"/>
+              <a:t> in </a:t>
+            </a:r>
+            <a:r>
+              <a:rPr lang="de-DE" dirty="0" err="1"/>
+              <a:t>equilibrium</a:t>
+            </a:r>
+            <a:endParaRPr lang="de-DE" dirty="0"/>
+          </a:p>
+          <a:p>
+            <a:r>
+              <a:rPr lang="de-DE" dirty="0">
+                <a:sym typeface="Wingdings" panose="05000000000000000000" pitchFamily="2" charset="2"/>
+              </a:rPr>
+              <a:t> </a:t>
+            </a:r>
+            <a:r>
+              <a:rPr lang="de-DE" dirty="0"/>
+              <a:t>Try different initial </a:t>
+            </a:r>
+            <a:r>
+              <a:rPr lang="de-DE" dirty="0" err="1"/>
+              <a:t>velocities</a:t>
+            </a:r>
+            <a:endParaRPr lang="de-CH" dirty="0"/>
+          </a:p>
+        </p:txBody>
+      </p:sp>
+      <p:sp>
+        <p:nvSpPr>
+          <p:cNvPr id="4" name="Fußzeilenplatzhalter 3">
+            <a:extLst>
+              <a:ext uri="{FF2B5EF4-FFF2-40B4-BE49-F238E27FC236}">
+                <a16:creationId xmlns:a16="http://schemas.microsoft.com/office/drawing/2014/main" id="{3F802F53-B6AE-4DB2-5B0D-0DA355B48C76}"/>
+              </a:ext>
+            </a:extLst>
+          </p:cNvPr>
+          <p:cNvSpPr>
+            <a:spLocks noGrp="1"/>
+          </p:cNvSpPr>
+          <p:nvPr>
+            <p:ph type="ftr" sz="quarter" idx="11"/>
+          </p:nvPr>
+        </p:nvSpPr>
+        <p:spPr/>
+        <p:txBody>
+          <a:bodyPr/>
+          <a:lstStyle/>
+          <a:p>
+            <a:r>
+              <a:rPr lang="de-CH"/>
+              <a:t>Diego Söldi</a:t>
+            </a:r>
+          </a:p>
+        </p:txBody>
+      </p:sp>
+      <p:sp>
+        <p:nvSpPr>
+          <p:cNvPr id="5" name="Foliennummernplatzhalter 4">
+            <a:extLst>
+              <a:ext uri="{FF2B5EF4-FFF2-40B4-BE49-F238E27FC236}">
+                <a16:creationId xmlns:a16="http://schemas.microsoft.com/office/drawing/2014/main" id="{A002EF43-D9F9-316B-94BB-DE19B04FCFFB}"/>
+              </a:ext>
+            </a:extLst>
+          </p:cNvPr>
+          <p:cNvSpPr>
+            <a:spLocks noGrp="1"/>
+          </p:cNvSpPr>
+          <p:nvPr>
+            <p:ph type="sldNum" sz="quarter" idx="12"/>
+          </p:nvPr>
+        </p:nvSpPr>
+        <p:spPr/>
+        <p:txBody>
+          <a:bodyPr/>
+          <a:lstStyle/>
+          <a:p>
+            <a:fld id="{79D1B373-AB7F-4F57-AEBA-BF7EB707F53C}" type="slidenum">
+              <a:rPr lang="de-CH" smtClean="0"/>
+              <a:t>8</a:t>
+            </a:fld>
+            <a:endParaRPr lang="de-CH"/>
+          </a:p>
+        </p:txBody>
+      </p:sp>
+    </p:spTree>
+    <p:extLst>
+      <p:ext uri="{BB962C8B-B14F-4D97-AF65-F5344CB8AC3E}">
+        <p14:creationId xmlns:p14="http://schemas.microsoft.com/office/powerpoint/2010/main" val="4166035770"/>
       </p:ext>
     </p:extLst>
   </p:cSld>

</xml_diff>